<commit_message>
Add slogan research (50 options scored) and top six in deck
Co-Authored-By: Claude Opus 5.5 <noreply@anthropic.com>
Claude-Session: https://claude.ai/code/session_01TPggK9YYJAqPjj1kZSx5tS
</commit_message>
<xml_diff>
--- a/Презентация (редактируемая).pptx
+++ b/Презентация (редактируемая).pptx
@@ -113,12 +113,12 @@
   <p:extLst>
     <p:ext uri="{521415D9-36F7-43E2-AB2F-B90AF26B5E84}">
       <p14:sectionLst xmlns:p14="http://schemas.microsoft.com/office/powerpoint/2010/main">
-        <p14:section name="Титул" id="{4ffe903e-099a-c623-8a72-73050a991739}">
+        <p14:section name="Титул" id="{00c9fd9e-7d01-30a0-268f-2669a947edad}">
           <p14:sldIdLst>
             <p14:sldId id="256"/>
           </p14:sldIdLst>
         </p14:section>
-        <p14:section name="Бизнес-модель" id="{f896d8ee-b482-cbdf-dbba-1d844eb840a6}">
+        <p14:section name="Бизнес-модель" id="{23550e22-a861-6ecb-c1f4-6b7b4e013e01}">
           <p14:sldIdLst>
             <p14:sldId id="257"/>
             <p14:sldId id="258"/>
@@ -126,12 +126,12 @@
             <p14:sldId id="260"/>
           </p14:sldIdLst>
         </p14:section>
-        <p14:section name="Позиционирование" id="{65046dc4-b00e-b12b-c224-d8cdd07624ef}">
+        <p14:section name="Позиционирование" id="{63a33d43-81ca-1264-76cf-f8fc080d7d61}">
           <p14:sldIdLst>
             <p14:sldId id="261"/>
           </p14:sldIdLst>
         </p14:section>
-        <p14:section name="Слоганы" id="{b2264e3e-3827-785b-fb1b-f75e49aab1c2}">
+        <p14:section name="Слоганы" id="{1b5d5dcc-e162-4f31-addc-2f4077ba694e}">
           <p14:sldIdLst>
             <p14:sldId id="262"/>
           </p14:sldIdLst>
@@ -8673,7 +8673,7 @@
                 <a:ea typeface="Arial Black" pitchFamily="34" charset="-122"/>
                 <a:cs typeface="Arial Black" pitchFamily="34" charset="-120"/>
               </a:rPr>
-              <a:t>«От вещи до карточки»</a:t>
+              <a:t>«Снимаем без фокусов»</a:t>
             </a:r>
             <a:endParaRPr lang="en-US" sz="2400" dirty="0"/>
           </a:p>
@@ -8774,7 +8774,7 @@
                 <a:ea typeface="Arial Black" pitchFamily="34" charset="-122"/>
                 <a:cs typeface="Arial Black" pitchFamily="34" charset="-120"/>
               </a:rPr>
-              <a:t>«Из показа — в заказ»</a:t>
+              <a:t>«Что на фото — то и в коробке»</a:t>
             </a:r>
             <a:endParaRPr lang="en-US" sz="2400" dirty="0"/>
           </a:p>
@@ -8875,7 +8875,7 @@
                 <a:ea typeface="Arial Black" pitchFamily="34" charset="-122"/>
                 <a:cs typeface="Arial Black" pitchFamily="34" charset="-120"/>
               </a:rPr>
-              <a:t>«Заказы вместо возвратов»</a:t>
+              <a:t>«Из показа — в заказ»</a:t>
             </a:r>
             <a:endParaRPr lang="en-US" sz="2400" dirty="0"/>
           </a:p>
@@ -8976,7 +8976,7 @@
                 <a:ea typeface="Arial Black" pitchFamily="34" charset="-122"/>
                 <a:cs typeface="Arial Black" pitchFamily="34" charset="-120"/>
               </a:rPr>
-              <a:t>«Для тех, кто продаёт своё»</a:t>
+              <a:t>«Тестируем, а не угадываем»</a:t>
             </a:r>
             <a:endParaRPr lang="en-US" sz="2400" dirty="0"/>
           </a:p>
@@ -9077,7 +9077,7 @@
                 <a:ea typeface="Arial Black" pitchFamily="34" charset="-122"/>
                 <a:cs typeface="Arial Black" pitchFamily="34" charset="-120"/>
               </a:rPr>
-              <a:t>«Честная карточка продаёт лучше»</a:t>
+              <a:t>«От вещи до карточки»</a:t>
             </a:r>
             <a:endParaRPr lang="en-US" sz="2400" dirty="0"/>
           </a:p>

</xml_diff>